<commit_message>
Ikinci denetim: belgeler, rapor, sunum ve one-pager duzeltildi
- makro-F1 0,5405 (yuvarlama hatasi) butun belgelerde
- 'valid satiri farklari kucultur' iddiasi geri cekildi: yon sinanmadi
- 'alt sinir' okumasinin varsayimi acikca yazildi (yanlis pozitifler rastgele degil)
- post-hoc saglamlik (seed duzeyi, maruziyet) SONUCLAR 4.6 ve rapor 7.3'te
- yeni sinirliliklar: SONUCLAR 7/17-19, rapor 9/6-8, deck A4/7-9
- deck ve one-pager yeniden uretildi; degisen slaytlar gozle kontrol edildi
- DECISIONS'a ikinci denetim kaydi; test sayisi 463

Co-Authored-By: Claude Opus 5 <noreply@anthropic.com>
Claude-Session: https://claude.ai/code/session_01Boyy948tsSoPXhsYxyoSPt
</commit_message>
<xml_diff>
--- a/presentation/SIC_AI_17_Group_2.pptx
+++ b/presentation/SIC_AI_17_Group_2.pptx
@@ -1433,7 +1433,7 @@
           <a:lstStyle/>
           <a:p>
             <a:r>
-              <a:t>Sinirliliklari juri sormadan biz soyluyoruz. Ilk uç madde dedektorun dogrulugu ve etiket guvenilirligiyle ilgili ve en agirlari. Dorduncusu ince ama onemli: C1 aslinda 'hediyeleri sil' degil 'dedektorun isaretledigini sil' kosulu. Besincisi sirali modele ozel. Altincisi bir kayit eksikligi ve artik duzeltildi - yeni kosular gerçek epoch sayisini yaziyor, ama gecmis yetmis iki kosu kurtarilamiyor. Geri kalan on madde SONUCLAR.md yedinci bolumde.</a:t>
+              <a:t>Sinirliliklari juri sormadan biz soyluyoruz. Ilk uç madde dedektorun dogrulugu ve etiket guvenilirligiyle ilgili ve en agirlari. Dorduncusu ince ama onemli: C1 aslinda 'hediyeleri sil' degil 'dedektorun isaretledigini sil' kosulu. Besincisi sirali modele ozel ve etkisinin yonu sinanmadi. Altincisi bir kayit eksikligi: seed 42'nin yirmi dort hucresi ayni veriyle yeniden kosuluyor. Yedi ve sekiz ikinci denetimde bulundu: guven araliklari egitim degiskenligini kapsamiyor ve plasebo kullanici duzeyinde eslenmedi - ikisi de post-hoc olculdu ve Toys bulgusunu degistirmiyor. Dokuzuncusu alt sinir okumasinin varsayimi. Geri kalan on madde SONUCLAR.md yedinci bolumde.</a:t>
             </a:r>
           </a:p>
         </p:txBody>
@@ -1853,7 +1853,7 @@
           <a:lstStyle/>
           <a:p>
             <a:r>
-              <a:t>Bu slaydi atlamiyoruz, aksine one aliyoruz. Concept note'ta iki esik yazmisiz: makro-F1 en az sifir yetmis bes ve hediye kesinligi en az sifir seksen. Olculen degerler sifir elli dort ve sifir altmis sekiz - ikisi de tutmuyor. Ayrica tek etiketleyici calisti, yani planlanan Fleiss kappa hic olculmedi; Hafta 4'un artefakttaki karari INCOMPLETE. Peki calisma neden hala okunabilir? Cunku etiket gurultusu hediye-silme kosulunu rastgele-silme plasebosuna YAKLASTIRIR; yani bulunan etki gercek etkinin alt siniri. Zayif dedektor bulgunun yonunu uydurmaz, ancak buyuklugunu kucultur.</a:t>
+              <a:t>Bu slaydi atlamiyoruz, aksine one aliyoruz. Concept note'ta iki esik yazmisiz: makro-F1 en az sifir yetmis bes ve hediye kesinligi en az sifir seksen. Olculen degerler sifir elli dort ve sifir altmis sekiz - ikisi de tutmuyor. Ayrica tek etiketleyici calisti, yani planlanan Fleiss kappa hic olculmedi; Hafta 4'un artefakttaki karari INCOMPLETE. Peki calisma neden hala okunabilir? Iki sey dedektorun dogruluguna bagli degil: plasebo silinen veri miktarini sabit tutuyor, ve etki kategorinin hediye payiyla buyuyor. Zayif dedektorun degistirdigi sey ne olculdugu: 'hediyeler' degil, dedektorun hediye DEDIGI satirlar. Bunlarin ucte biri insana gore hediye degil, cogu kendi cocuguna alim - o yuzden 'alt sinir' okumasi bir varsayima dayaniyor, A4'te yaziyor.</a:t>
             </a:r>
           </a:p>
         </p:txBody>
@@ -5275,7 +5275,7 @@
                 </a:solidFill>
                 <a:latin typeface="Calibri"/>
               </a:rPr>
-              <a:t>github.com/edasaruhan/SIC_AI_17_Capstone_Group_2  ·  20 September 2026</a:t>
+              <a:t>github.com/edasaruhan/SIC_AI_17_Capstone_Group_2  ·  21 September 2026</a:t>
             </a:r>
           </a:p>
           <a:p>
@@ -21963,8 +21963,8 @@
           <p:nvPr/>
         </p:nvGraphicFramePr>
         <p:xfrm>
-          <a:off x="658368" y="1847088"/>
-          <a:ext cx="10874958" cy="3328416"/>
+          <a:off x="658368" y="1783080"/>
+          <a:ext cx="10874958" cy="3749040"/>
         </p:xfrm>
         <a:graphic>
           <a:graphicData uri="http://schemas.openxmlformats.org/drawingml/2006/table">
@@ -21977,7 +21977,7 @@
                 <a:gridCol w="5483172"/>
                 <a:gridCol w="4843469"/>
               </a:tblGrid>
-              <a:tr h="475488">
+              <a:tr h="374904">
                 <a:tc>
                   <a:txBody>
                     <a:bodyPr/>
@@ -21992,19 +21992,111 @@
                         </a:spcAft>
                       </a:pPr>
                       <a:r>
+                        <a:rPr sz="900" b="1" i="0">
+                          <a:solidFill>
+                            <a:srgbClr val="1F5C8B"/>
+                          </a:solidFill>
+                          <a:latin typeface="Calibri"/>
+                        </a:rPr>
+                        <a:t>#</a:t>
+                      </a:r>
+                    </a:p>
+                  </a:txBody>
+                  <a:tcPr marL="73152" marR="73152" marT="18288" marB="18288" anchor="ctr">
+                    <a:solidFill>
+                      <a:srgbClr val="E8EFF6"/>
+                    </a:solidFill>
+                  </a:tcPr>
+                </a:tc>
+                <a:tc>
+                  <a:txBody>
+                    <a:bodyPr/>
+                    <a:lstStyle/>
+                    <a:p>
+                      <a:pPr algn="l">
+                        <a:spcBef>
+                          <a:spcPts val="0"/>
+                        </a:spcBef>
+                        <a:spcAft>
+                          <a:spcPts val="0"/>
+                        </a:spcAft>
+                      </a:pPr>
+                      <a:r>
+                        <a:rPr sz="900" b="1" i="0">
+                          <a:solidFill>
+                            <a:srgbClr val="1F5C8B"/>
+                          </a:solidFill>
+                          <a:latin typeface="Calibri"/>
+                        </a:rPr>
+                        <a:t>Limitation</a:t>
+                      </a:r>
+                    </a:p>
+                  </a:txBody>
+                  <a:tcPr marL="73152" marR="73152" marT="18288" marB="18288" anchor="ctr">
+                    <a:solidFill>
+                      <a:srgbClr val="E8EFF6"/>
+                    </a:solidFill>
+                  </a:tcPr>
+                </a:tc>
+                <a:tc>
+                  <a:txBody>
+                    <a:bodyPr/>
+                    <a:lstStyle/>
+                    <a:p>
+                      <a:pPr algn="l">
+                        <a:spcBef>
+                          <a:spcPts val="0"/>
+                        </a:spcBef>
+                        <a:spcAft>
+                          <a:spcPts val="0"/>
+                        </a:spcAft>
+                      </a:pPr>
+                      <a:r>
+                        <a:rPr sz="900" b="1" i="0">
+                          <a:solidFill>
+                            <a:srgbClr val="1F5C8B"/>
+                          </a:solidFill>
+                          <a:latin typeface="Calibri"/>
+                        </a:rPr>
+                        <a:t>What it costs the conclusion</a:t>
+                      </a:r>
+                    </a:p>
+                  </a:txBody>
+                  <a:tcPr marL="73152" marR="73152" marT="18288" marB="18288" anchor="ctr">
+                    <a:solidFill>
+                      <a:srgbClr val="E8EFF6"/>
+                    </a:solidFill>
+                  </a:tcPr>
+                </a:tc>
+              </a:tr>
+              <a:tr h="374904">
+                <a:tc>
+                  <a:txBody>
+                    <a:bodyPr/>
+                    <a:lstStyle/>
+                    <a:p>
+                      <a:pPr algn="l">
+                        <a:spcBef>
+                          <a:spcPts val="0"/>
+                        </a:spcBef>
+                        <a:spcAft>
+                          <a:spcPts val="0"/>
+                        </a:spcAft>
+                      </a:pPr>
+                      <a:r>
                         <a:rPr sz="950" b="1" i="0">
                           <a:solidFill>
-                            <a:srgbClr val="1F5C8B"/>
-                          </a:solidFill>
-                          <a:latin typeface="Calibri"/>
-                        </a:rPr>
-                        <a:t>#</a:t>
-                      </a:r>
-                    </a:p>
-                  </a:txBody>
-                  <a:tcPr marL="73152" marR="73152" marT="18288" marB="18288" anchor="ctr">
-                    <a:solidFill>
-                      <a:srgbClr val="E8EFF6"/>
+                            <a:srgbClr val="1C1C1C"/>
+                          </a:solidFill>
+                          <a:latin typeface="Calibri"/>
+                        </a:rPr>
+                        <a:t>1</a:t>
+                      </a:r>
+                    </a:p>
+                  </a:txBody>
+                  <a:tcPr marL="73152" marR="73152" marT="18288" marB="18288" anchor="ctr">
+                    <a:solidFill>
+                      <a:srgbClr val="FFFFFF"/>
                     </a:solidFill>
                   </a:tcPr>
                 </a:tc>
@@ -22022,19 +22114,81 @@
                         </a:spcAft>
                       </a:pPr>
                       <a:r>
+                        <a:rPr sz="950" b="0" i="0">
+                          <a:solidFill>
+                            <a:srgbClr val="1C1C1C"/>
+                          </a:solidFill>
+                          <a:latin typeface="Calibri"/>
+                        </a:rPr>
+                        <a:t>Two pre-registered detector gates were missed (macro-F1 0.5405 vs ≥ 0.75; gift precision 0.68 vs ≥ 0.80)</a:t>
+                      </a:r>
+                    </a:p>
+                  </a:txBody>
+                  <a:tcPr marL="73152" marR="73152" marT="18288" marB="18288" anchor="ctr">
+                    <a:solidFill>
+                      <a:srgbClr val="FFFFFF"/>
+                    </a:solidFill>
+                  </a:tcPr>
+                </a:tc>
+                <a:tc>
+                  <a:txBody>
+                    <a:bodyPr/>
+                    <a:lstStyle/>
+                    <a:p>
+                      <a:pPr algn="l">
+                        <a:spcBef>
+                          <a:spcPts val="0"/>
+                        </a:spcBef>
+                        <a:spcAft>
+                          <a:spcPts val="0"/>
+                        </a:spcAft>
+                      </a:pPr>
+                      <a:r>
+                        <a:rPr sz="950" b="0" i="0">
+                          <a:solidFill>
+                            <a:srgbClr val="1C1C1C"/>
+                          </a:solidFill>
+                          <a:latin typeface="Calibri"/>
+                        </a:rPr>
+                        <a:t>Absolute prevalence is uncertain; effects measure detector-flagged rows</a:t>
+                      </a:r>
+                    </a:p>
+                  </a:txBody>
+                  <a:tcPr marL="73152" marR="73152" marT="18288" marB="18288" anchor="ctr">
+                    <a:solidFill>
+                      <a:srgbClr val="FFFFFF"/>
+                    </a:solidFill>
+                  </a:tcPr>
+                </a:tc>
+              </a:tr>
+              <a:tr h="374904">
+                <a:tc>
+                  <a:txBody>
+                    <a:bodyPr/>
+                    <a:lstStyle/>
+                    <a:p>
+                      <a:pPr algn="l">
+                        <a:spcBef>
+                          <a:spcPts val="0"/>
+                        </a:spcBef>
+                        <a:spcAft>
+                          <a:spcPts val="0"/>
+                        </a:spcAft>
+                      </a:pPr>
+                      <a:r>
                         <a:rPr sz="950" b="1" i="0">
                           <a:solidFill>
-                            <a:srgbClr val="1F5C8B"/>
-                          </a:solidFill>
-                          <a:latin typeface="Calibri"/>
-                        </a:rPr>
-                        <a:t>Limitation</a:t>
-                      </a:r>
-                    </a:p>
-                  </a:txBody>
-                  <a:tcPr marL="73152" marR="73152" marT="18288" marB="18288" anchor="ctr">
-                    <a:solidFill>
-                      <a:srgbClr val="E8EFF6"/>
+                            <a:srgbClr val="1C1C1C"/>
+                          </a:solidFill>
+                          <a:latin typeface="Calibri"/>
+                        </a:rPr>
+                        <a:t>2</a:t>
+                      </a:r>
+                    </a:p>
+                  </a:txBody>
+                  <a:tcPr marL="73152" marR="73152" marT="18288" marB="18288" anchor="ctr">
+                    <a:solidFill>
+                      <a:srgbClr val="FAFAFA"/>
                     </a:solidFill>
                   </a:tcPr>
                 </a:tc>
@@ -22052,24 +22206,146 @@
                         </a:spcAft>
                       </a:pPr>
                       <a:r>
+                        <a:rPr sz="950" b="0" i="0">
+                          <a:solidFill>
+                            <a:srgbClr val="1C1C1C"/>
+                          </a:solidFill>
+                          <a:latin typeface="Calibri"/>
+                        </a:rPr>
+                        <a:t>The primary metric changed from NDCG@10 to Recall@10 before the runs</a:t>
+                      </a:r>
+                    </a:p>
+                  </a:txBody>
+                  <a:tcPr marL="73152" marR="73152" marT="18288" marB="18288" anchor="ctr">
+                    <a:solidFill>
+                      <a:srgbClr val="FAFAFA"/>
+                    </a:solidFill>
+                  </a:tcPr>
+                </a:tc>
+                <a:tc>
+                  <a:txBody>
+                    <a:bodyPr/>
+                    <a:lstStyle/>
+                    <a:p>
+                      <a:pPr algn="l">
+                        <a:spcBef>
+                          <a:spcPts val="0"/>
+                        </a:spcBef>
+                        <a:spcAft>
+                          <a:spcPts val="0"/>
+                        </a:spcAft>
+                      </a:pPr>
+                      <a:r>
+                        <a:rPr sz="950" b="0" i="0">
+                          <a:solidFill>
+                            <a:srgbClr val="1C1C1C"/>
+                          </a:solidFill>
+                          <a:latin typeface="Calibri"/>
+                        </a:rPr>
+                        <a:t>Pre-registered, dated, and NDCG is still reported — but it is a change</a:t>
+                      </a:r>
+                    </a:p>
+                  </a:txBody>
+                  <a:tcPr marL="73152" marR="73152" marT="18288" marB="18288" anchor="ctr">
+                    <a:solidFill>
+                      <a:srgbClr val="FAFAFA"/>
+                    </a:solidFill>
+                  </a:tcPr>
+                </a:tc>
+              </a:tr>
+              <a:tr h="374904">
+                <a:tc>
+                  <a:txBody>
+                    <a:bodyPr/>
+                    <a:lstStyle/>
+                    <a:p>
+                      <a:pPr algn="l">
+                        <a:spcBef>
+                          <a:spcPts val="0"/>
+                        </a:spcBef>
+                        <a:spcAft>
+                          <a:spcPts val="0"/>
+                        </a:spcAft>
+                      </a:pPr>
+                      <a:r>
                         <a:rPr sz="950" b="1" i="0">
                           <a:solidFill>
-                            <a:srgbClr val="1F5C8B"/>
-                          </a:solidFill>
-                          <a:latin typeface="Calibri"/>
-                        </a:rPr>
-                        <a:t>What it costs the conclusion</a:t>
-                      </a:r>
-                    </a:p>
-                  </a:txBody>
-                  <a:tcPr marL="73152" marR="73152" marT="18288" marB="18288" anchor="ctr">
-                    <a:solidFill>
-                      <a:srgbClr val="E8EFF6"/>
+                            <a:srgbClr val="1C1C1C"/>
+                          </a:solidFill>
+                          <a:latin typeface="Calibri"/>
+                        </a:rPr>
+                        <a:t>3</a:t>
+                      </a:r>
+                    </a:p>
+                  </a:txBody>
+                  <a:tcPr marL="73152" marR="73152" marT="18288" marB="18288" anchor="ctr">
+                    <a:solidFill>
+                      <a:srgbClr val="FFFFFF"/>
+                    </a:solidFill>
+                  </a:tcPr>
+                </a:tc>
+                <a:tc>
+                  <a:txBody>
+                    <a:bodyPr/>
+                    <a:lstStyle/>
+                    <a:p>
+                      <a:pPr algn="l">
+                        <a:spcBef>
+                          <a:spcPts val="0"/>
+                        </a:spcBef>
+                        <a:spcAft>
+                          <a:spcPts val="0"/>
+                        </a:spcAft>
+                      </a:pPr>
+                      <a:r>
+                        <a:rPr sz="950" b="0" i="0">
+                          <a:solidFill>
+                            <a:srgbClr val="1C1C1C"/>
+                          </a:solidFill>
+                          <a:latin typeface="Calibri"/>
+                        </a:rPr>
+                        <a:t>1 human annotator; the planned Fleiss κ was never measured</a:t>
+                      </a:r>
+                    </a:p>
+                  </a:txBody>
+                  <a:tcPr marL="73152" marR="73152" marT="18288" marB="18288" anchor="ctr">
+                    <a:solidFill>
+                      <a:srgbClr val="FFFFFF"/>
+                    </a:solidFill>
+                  </a:tcPr>
+                </a:tc>
+                <a:tc>
+                  <a:txBody>
+                    <a:bodyPr/>
+                    <a:lstStyle/>
+                    <a:p>
+                      <a:pPr algn="l">
+                        <a:spcBef>
+                          <a:spcPts val="0"/>
+                        </a:spcBef>
+                        <a:spcAft>
+                          <a:spcPts val="0"/>
+                        </a:spcAft>
+                      </a:pPr>
+                      <a:r>
+                        <a:rPr sz="950" b="0" i="0">
+                          <a:solidFill>
+                            <a:srgbClr val="1C1C1C"/>
+                          </a:solidFill>
+                          <a:latin typeface="Calibri"/>
+                        </a:rPr>
+                        <a:t>No reliability estimate for the reference labels themselves</a:t>
+                      </a:r>
+                    </a:p>
+                  </a:txBody>
+                  <a:tcPr marL="73152" marR="73152" marT="18288" marB="18288" anchor="ctr">
+                    <a:solidFill>
+                      <a:srgbClr val="FFFFFF"/>
                     </a:solidFill>
                   </a:tcPr>
                 </a:tc>
               </a:tr>
-              <a:tr h="475488">
+              <a:tr h="374904">
                 <a:tc>
                   <a:txBody>
                     <a:bodyPr/>
@@ -22084,13 +22360,105 @@
                         </a:spcAft>
                       </a:pPr>
                       <a:r>
-                        <a:rPr sz="1000" b="1" i="0">
-                          <a:solidFill>
-                            <a:srgbClr val="1C1C1C"/>
-                          </a:solidFill>
-                          <a:latin typeface="Calibri"/>
-                        </a:rPr>
-                        <a:t>1</a:t>
+                        <a:rPr sz="950" b="1" i="0">
+                          <a:solidFill>
+                            <a:srgbClr val="1C1C1C"/>
+                          </a:solidFill>
+                          <a:latin typeface="Calibri"/>
+                        </a:rPr>
+                        <a:t>4</a:t>
+                      </a:r>
+                    </a:p>
+                  </a:txBody>
+                  <a:tcPr marL="73152" marR="73152" marT="18288" marB="18288" anchor="ctr">
+                    <a:solidFill>
+                      <a:srgbClr val="FAFAFA"/>
+                    </a:solidFill>
+                  </a:tcPr>
+                </a:tc>
+                <a:tc>
+                  <a:txBody>
+                    <a:bodyPr/>
+                    <a:lstStyle/>
+                    <a:p>
+                      <a:pPr algn="l">
+                        <a:spcBef>
+                          <a:spcPts val="0"/>
+                        </a:spcBef>
+                        <a:spcAft>
+                          <a:spcPts val="0"/>
+                        </a:spcAft>
+                      </a:pPr>
+                      <a:r>
+                        <a:rPr sz="950" b="0" i="0">
+                          <a:solidFill>
+                            <a:srgbClr val="1C1C1C"/>
+                          </a:solidFill>
+                          <a:latin typeface="Calibri"/>
+                        </a:rPr>
+                        <a:t>C1 deletes rows the detector believes are gifts, including its false positives</a:t>
+                      </a:r>
+                    </a:p>
+                  </a:txBody>
+                  <a:tcPr marL="73152" marR="73152" marT="18288" marB="18288" anchor="ctr">
+                    <a:solidFill>
+                      <a:srgbClr val="FAFAFA"/>
+                    </a:solidFill>
+                  </a:tcPr>
+                </a:tc>
+                <a:tc>
+                  <a:txBody>
+                    <a:bodyPr/>
+                    <a:lstStyle/>
+                    <a:p>
+                      <a:pPr algn="l">
+                        <a:spcBef>
+                          <a:spcPts val="0"/>
+                        </a:spcBef>
+                        <a:spcAft>
+                          <a:spcPts val="0"/>
+                        </a:spcAft>
+                      </a:pPr>
+                      <a:r>
+                        <a:rPr sz="950" b="0" i="0">
+                          <a:solidFill>
+                            <a:srgbClr val="1C1C1C"/>
+                          </a:solidFill>
+                          <a:latin typeface="Calibri"/>
+                        </a:rPr>
+                        <a:t>The treatment is "delete what the detector flags", not "delete gifts"</a:t>
+                      </a:r>
+                    </a:p>
+                  </a:txBody>
+                  <a:tcPr marL="73152" marR="73152" marT="18288" marB="18288" anchor="ctr">
+                    <a:solidFill>
+                      <a:srgbClr val="FAFAFA"/>
+                    </a:solidFill>
+                  </a:tcPr>
+                </a:tc>
+              </a:tr>
+              <a:tr h="374904">
+                <a:tc>
+                  <a:txBody>
+                    <a:bodyPr/>
+                    <a:lstStyle/>
+                    <a:p>
+                      <a:pPr algn="l">
+                        <a:spcBef>
+                          <a:spcPts val="0"/>
+                        </a:spcBef>
+                        <a:spcAft>
+                          <a:spcPts val="0"/>
+                        </a:spcAft>
+                      </a:pPr>
+                      <a:r>
+                        <a:rPr sz="950" b="1" i="0">
+                          <a:solidFill>
+                            <a:srgbClr val="1C1C1C"/>
+                          </a:solidFill>
+                          <a:latin typeface="Calibri"/>
+                        </a:rPr>
+                        <a:t>5</a:t>
                       </a:r>
                     </a:p>
                   </a:txBody>
@@ -22114,13 +22482,13 @@
                         </a:spcAft>
                       </a:pPr>
                       <a:r>
-                        <a:rPr sz="1000" b="0" i="0">
-                          <a:solidFill>
-                            <a:srgbClr val="1C1C1C"/>
-                          </a:solidFill>
-                          <a:latin typeface="Calibri"/>
-                        </a:rPr>
-                        <a:t>Two pre-registered detector gates were missed (macro-F1 0.5404 vs ≥ 0.75; gift precision 0.68 vs ≥ 0.80)</a:t>
+                        <a:rPr sz="950" b="0" i="0">
+                          <a:solidFill>
+                            <a:srgbClr val="1C1C1C"/>
+                          </a:solidFill>
+                          <a:latin typeface="Calibri"/>
+                        </a:rPr>
+                        <a:t>Gifts in a user's validation row are never removed</a:t>
                       </a:r>
                     </a:p>
                   </a:txBody>
@@ -22144,13 +22512,13 @@
                         </a:spcAft>
                       </a:pPr>
                       <a:r>
-                        <a:rPr sz="1000" b="0" i="0">
-                          <a:solidFill>
-                            <a:srgbClr val="1C1C1C"/>
-                          </a:solidFill>
-                          <a:latin typeface="Calibri"/>
-                        </a:rPr>
-                        <a:t>Effects are lower bounds; absolute prevalence is uncertain</a:t>
+                        <a:rPr sz="950" b="0" i="0">
+                          <a:solidFill>
+                            <a:srgbClr val="1C1C1C"/>
+                          </a:solidFill>
+                          <a:latin typeface="Calibri"/>
+                        </a:rPr>
+                        <a:t>Direction of the effect on the sequential model is untested</a:t>
                       </a:r>
                     </a:p>
                   </a:txBody>
@@ -22161,7 +22529,7 @@
                   </a:tcPr>
                 </a:tc>
               </a:tr>
-              <a:tr h="475488">
+              <a:tr h="374904">
                 <a:tc>
                   <a:txBody>
                     <a:bodyPr/>
@@ -22176,13 +22544,13 @@
                         </a:spcAft>
                       </a:pPr>
                       <a:r>
-                        <a:rPr sz="1000" b="1" i="0">
-                          <a:solidFill>
-                            <a:srgbClr val="1C1C1C"/>
-                          </a:solidFill>
-                          <a:latin typeface="Calibri"/>
-                        </a:rPr>
-                        <a:t>2</a:t>
+                        <a:rPr sz="950" b="1" i="0">
+                          <a:solidFill>
+                            <a:srgbClr val="1C1C1C"/>
+                          </a:solidFill>
+                          <a:latin typeface="Calibri"/>
+                        </a:rPr>
+                        <a:t>6</a:t>
                       </a:r>
                     </a:p>
                   </a:txBody>
@@ -22206,13 +22574,13 @@
                         </a:spcAft>
                       </a:pPr>
                       <a:r>
-                        <a:rPr sz="1000" b="0" i="0">
-                          <a:solidFill>
-                            <a:srgbClr val="1C1C1C"/>
-                          </a:solidFill>
-                          <a:latin typeface="Calibri"/>
-                        </a:rPr>
-                        <a:t>The primary metric changed from NDCG@10 to Recall@10 before the runs</a:t>
+                        <a:rPr sz="950" b="0" i="0">
+                          <a:solidFill>
+                            <a:srgbClr val="1C1C1C"/>
+                          </a:solidFill>
+                          <a:latin typeface="Calibri"/>
+                        </a:rPr>
+                        <a:t>Number of epochs actually trained was not recorded for the 72 runs</a:t>
                       </a:r>
                     </a:p>
                   </a:txBody>
@@ -22236,13 +22604,13 @@
                         </a:spcAft>
                       </a:pPr>
                       <a:r>
-                        <a:rPr sz="1000" b="0" i="0">
-                          <a:solidFill>
-                            <a:srgbClr val="1C1C1C"/>
-                          </a:solidFill>
-                          <a:latin typeface="Calibri"/>
-                        </a:rPr>
-                        <a:t>Pre-registered, dated, and NDCG is still reported — but it is a change</a:t>
+                        <a:rPr sz="950" b="0" i="0">
+                          <a:solidFill>
+                            <a:srgbClr val="1C1C1C"/>
+                          </a:solidFill>
+                          <a:latin typeface="Calibri"/>
+                        </a:rPr>
+                        <a:t>Seed-42 cells re-run on 21 Sept with the same data to measure it</a:t>
                       </a:r>
                     </a:p>
                   </a:txBody>
@@ -22253,7 +22621,7 @@
                   </a:tcPr>
                 </a:tc>
               </a:tr>
-              <a:tr h="475488">
+              <a:tr h="374904">
                 <a:tc>
                   <a:txBody>
                     <a:bodyPr/>
@@ -22268,13 +22636,13 @@
                         </a:spcAft>
                       </a:pPr>
                       <a:r>
-                        <a:rPr sz="1000" b="1" i="0">
-                          <a:solidFill>
-                            <a:srgbClr val="1C1C1C"/>
-                          </a:solidFill>
-                          <a:latin typeface="Calibri"/>
-                        </a:rPr>
-                        <a:t>3</a:t>
+                        <a:rPr sz="950" b="1" i="0">
+                          <a:solidFill>
+                            <a:srgbClr val="1C1C1C"/>
+                          </a:solidFill>
+                          <a:latin typeface="Calibri"/>
+                        </a:rPr>
+                        <a:t>7</a:t>
                       </a:r>
                     </a:p>
                   </a:txBody>
@@ -22298,13 +22666,13 @@
                         </a:spcAft>
                       </a:pPr>
                       <a:r>
-                        <a:rPr sz="1000" b="0" i="0">
-                          <a:solidFill>
-                            <a:srgbClr val="1C1C1C"/>
-                          </a:solidFill>
-                          <a:latin typeface="Calibri"/>
-                        </a:rPr>
-                        <a:t>1 human annotator; the planned Fleiss κ was never measured</a:t>
+                        <a:rPr sz="950" b="0" i="0">
+                          <a:solidFill>
+                            <a:srgbClr val="1C1C1C"/>
+                          </a:solidFill>
+                          <a:latin typeface="Calibri"/>
+                        </a:rPr>
+                        <a:t>Intervals resample users, not training runs (seed variance excluded)</a:t>
                       </a:r>
                     </a:p>
                   </a:txBody>
@@ -22328,13 +22696,13 @@
                         </a:spcAft>
                       </a:pPr>
                       <a:r>
-                        <a:rPr sz="1000" b="0" i="0">
-                          <a:solidFill>
-                            <a:srgbClr val="1C1C1C"/>
-                          </a:solidFill>
-                          <a:latin typeface="Calibri"/>
-                        </a:rPr>
-                        <a:t>No reliability estimate for the reference labels themselves</a:t>
+                        <a:rPr sz="950" b="0" i="0">
+                          <a:solidFill>
+                            <a:srgbClr val="1C1C1C"/>
+                          </a:solidFill>
+                          <a:latin typeface="Calibri"/>
+                        </a:rPr>
+                        <a:t>Toys: every seed agrees in sign · Grocery: seed spread ≈ interval width</a:t>
                       </a:r>
                     </a:p>
                   </a:txBody>
@@ -22345,7 +22713,7 @@
                   </a:tcPr>
                 </a:tc>
               </a:tr>
-              <a:tr h="475488">
+              <a:tr h="374904">
                 <a:tc>
                   <a:txBody>
                     <a:bodyPr/>
@@ -22360,13 +22728,13 @@
                         </a:spcAft>
                       </a:pPr>
                       <a:r>
-                        <a:rPr sz="1000" b="1" i="0">
-                          <a:solidFill>
-                            <a:srgbClr val="1C1C1C"/>
-                          </a:solidFill>
-                          <a:latin typeface="Calibri"/>
-                        </a:rPr>
-                        <a:t>4</a:t>
+                        <a:rPr sz="950" b="1" i="0">
+                          <a:solidFill>
+                            <a:srgbClr val="1C1C1C"/>
+                          </a:solidFill>
+                          <a:latin typeface="Calibri"/>
+                        </a:rPr>
+                        <a:t>8</a:t>
                       </a:r>
                     </a:p>
                   </a:txBody>
@@ -22390,13 +22758,13 @@
                         </a:spcAft>
                       </a:pPr>
                       <a:r>
-                        <a:rPr sz="1000" b="0" i="0">
-                          <a:solidFill>
-                            <a:srgbClr val="1C1C1C"/>
-                          </a:solidFill>
-                          <a:latin typeface="Calibri"/>
-                        </a:rPr>
-                        <a:t>C1 deletes rows the detector believes are gifts, including its false positives</a:t>
+                        <a:rPr sz="950" b="0" i="0">
+                          <a:solidFill>
+                            <a:srgbClr val="1C1C1C"/>
+                          </a:solidFill>
+                          <a:latin typeface="Calibri"/>
+                        </a:rPr>
+                        <a:t>The placebo matches the number of rows, not the users they come from</a:t>
                       </a:r>
                     </a:p>
                   </a:txBody>
@@ -22420,13 +22788,13 @@
                         </a:spcAft>
                       </a:pPr>
                       <a:r>
-                        <a:rPr sz="1000" b="0" i="0">
-                          <a:solidFill>
-                            <a:srgbClr val="1C1C1C"/>
-                          </a:solidFill>
-                          <a:latin typeface="Calibri"/>
-                        </a:rPr>
-                        <a:t>The treatment is "delete what the detector flags", not "delete gifts"</a:t>
+                        <a:rPr sz="950" b="0" i="0">
+                          <a:solidFill>
+                            <a:srgbClr val="1C1C1C"/>
+                          </a:solidFill>
+                          <a:latin typeface="Calibri"/>
+                        </a:rPr>
+                        <a:t>Post-hoc: the Toys effect holds even for users neither condition touched</a:t>
                       </a:r>
                     </a:p>
                   </a:txBody>
@@ -22437,7 +22805,7 @@
                   </a:tcPr>
                 </a:tc>
               </a:tr>
-              <a:tr h="475488">
+              <a:tr h="374904">
                 <a:tc>
                   <a:txBody>
                     <a:bodyPr/>
@@ -22452,13 +22820,13 @@
                         </a:spcAft>
                       </a:pPr>
                       <a:r>
-                        <a:rPr sz="1000" b="1" i="0">
-                          <a:solidFill>
-                            <a:srgbClr val="1C1C1C"/>
-                          </a:solidFill>
-                          <a:latin typeface="Calibri"/>
-                        </a:rPr>
-                        <a:t>5</a:t>
+                        <a:rPr sz="950" b="1" i="0">
+                          <a:solidFill>
+                            <a:srgbClr val="1C1C1C"/>
+                          </a:solidFill>
+                          <a:latin typeface="Calibri"/>
+                        </a:rPr>
+                        <a:t>9</a:t>
                       </a:r>
                     </a:p>
                   </a:txBody>
@@ -22482,13 +22850,13 @@
                         </a:spcAft>
                       </a:pPr>
                       <a:r>
-                        <a:rPr sz="1000" b="0" i="0">
-                          <a:solidFill>
-                            <a:srgbClr val="1C1C1C"/>
-                          </a:solidFill>
-                          <a:latin typeface="Calibri"/>
-                        </a:rPr>
-                        <a:t>Gifts in a user's validation row are never removed</a:t>
+                        <a:rPr sz="950" b="0" i="0">
+                          <a:solidFill>
+                            <a:srgbClr val="1C1C1C"/>
+                          </a:solidFill>
+                          <a:latin typeface="Calibri"/>
+                        </a:rPr>
+                        <a:t>"Lower bound" assumes false positives are as informative as random rows</a:t>
                       </a:r>
                     </a:p>
                   </a:txBody>
@@ -22512,111 +22880,19 @@
                         </a:spcAft>
                       </a:pPr>
                       <a:r>
-                        <a:rPr sz="1000" b="0" i="0">
-                          <a:solidFill>
-                            <a:srgbClr val="1C1C1C"/>
-                          </a:solidFill>
-                          <a:latin typeface="Calibri"/>
-                        </a:rPr>
-                        <a:t>Weakens C1 for the sequential model specifically</a:t>
+                        <a:rPr sz="950" b="0" i="0">
+                          <a:solidFill>
+                            <a:srgbClr val="1C1C1C"/>
+                          </a:solidFill>
+                          <a:latin typeface="Calibri"/>
+                        </a:rPr>
+                        <a:t>Most are purchases for the buyer's own child — not guaranteed</a:t>
                       </a:r>
                     </a:p>
                   </a:txBody>
                   <a:tcPr marL="73152" marR="73152" marT="18288" marB="18288" anchor="ctr">
                     <a:solidFill>
                       <a:srgbClr val="FFFFFF"/>
-                    </a:solidFill>
-                  </a:tcPr>
-                </a:tc>
-              </a:tr>
-              <a:tr h="475488">
-                <a:tc>
-                  <a:txBody>
-                    <a:bodyPr/>
-                    <a:lstStyle/>
-                    <a:p>
-                      <a:pPr algn="l">
-                        <a:spcBef>
-                          <a:spcPts val="0"/>
-                        </a:spcBef>
-                        <a:spcAft>
-                          <a:spcPts val="0"/>
-                        </a:spcAft>
-                      </a:pPr>
-                      <a:r>
-                        <a:rPr sz="1000" b="1" i="0">
-                          <a:solidFill>
-                            <a:srgbClr val="1C1C1C"/>
-                          </a:solidFill>
-                          <a:latin typeface="Calibri"/>
-                        </a:rPr>
-                        <a:t>6</a:t>
-                      </a:r>
-                    </a:p>
-                  </a:txBody>
-                  <a:tcPr marL="73152" marR="73152" marT="18288" marB="18288" anchor="ctr">
-                    <a:solidFill>
-                      <a:srgbClr val="FAFAFA"/>
-                    </a:solidFill>
-                  </a:tcPr>
-                </a:tc>
-                <a:tc>
-                  <a:txBody>
-                    <a:bodyPr/>
-                    <a:lstStyle/>
-                    <a:p>
-                      <a:pPr algn="l">
-                        <a:spcBef>
-                          <a:spcPts val="0"/>
-                        </a:spcBef>
-                        <a:spcAft>
-                          <a:spcPts val="0"/>
-                        </a:spcAft>
-                      </a:pPr>
-                      <a:r>
-                        <a:rPr sz="1000" b="0" i="0">
-                          <a:solidFill>
-                            <a:srgbClr val="1C1C1C"/>
-                          </a:solidFill>
-                          <a:latin typeface="Calibri"/>
-                        </a:rPr>
-                        <a:t>Number of epochs actually trained was not recorded for the 72 runs</a:t>
-                      </a:r>
-                    </a:p>
-                  </a:txBody>
-                  <a:tcPr marL="73152" marR="73152" marT="18288" marB="18288" anchor="ctr">
-                    <a:solidFill>
-                      <a:srgbClr val="FAFAFA"/>
-                    </a:solidFill>
-                  </a:tcPr>
-                </a:tc>
-                <a:tc>
-                  <a:txBody>
-                    <a:bodyPr/>
-                    <a:lstStyle/>
-                    <a:p>
-                      <a:pPr algn="l">
-                        <a:spcBef>
-                          <a:spcPts val="0"/>
-                        </a:spcBef>
-                        <a:spcAft>
-                          <a:spcPts val="0"/>
-                        </a:spcAft>
-                      </a:pPr>
-                      <a:r>
-                        <a:rPr sz="1000" b="0" i="0">
-                          <a:solidFill>
-                            <a:srgbClr val="1C1C1C"/>
-                          </a:solidFill>
-                          <a:latin typeface="Calibri"/>
-                        </a:rPr>
-                        <a:t>Now written to every new run report; the old runs cannot be recovered</a:t>
-                      </a:r>
-                    </a:p>
-                  </a:txBody>
-                  <a:tcPr marL="73152" marR="73152" marT="18288" marB="18288" anchor="ctr">
-                    <a:solidFill>
-                      <a:srgbClr val="FAFAFA"/>
                     </a:solidFill>
                   </a:tcPr>
                 </a:tc>
@@ -22633,8 +22909,8 @@
         </p:nvSpPr>
         <p:spPr>
           <a:xfrm>
-            <a:off x="658368" y="5230368"/>
-            <a:ext cx="10874959" cy="1005840"/>
+            <a:off x="658368" y="5650992"/>
+            <a:ext cx="10874959" cy="731520"/>
           </a:xfrm>
           <a:prstGeom prst="rect">
             <a:avLst/>
@@ -23185,7 +23461,7 @@
                 </a:solidFill>
                 <a:latin typeface="Calibri"/>
               </a:rPr>
-              <a:t>•  prevalence.json — code_version 791d9d4</a:t>
+              <a:t>•  prevalence.json — code_version 05df87b</a:t>
             </a:r>
           </a:p>
           <a:p>
@@ -23242,7 +23518,7 @@
                 </a:solidFill>
                 <a:latin typeface="Calibri"/>
               </a:rPr>
-              <a:t>•  marketing_metrics.json — code_version 3f904a6-dirty</a:t>
+              <a:t>•  marketing_metrics.json — code_version 3058448</a:t>
             </a:r>
           </a:p>
           <a:p>
@@ -25488,7 +25764,7 @@
                 </a:solidFill>
                 <a:latin typeface="Calibri"/>
               </a:rPr>
-              <a:t>A 95 % bootstrap interval that excludes zero in the expected direction → reported as a LOWER BOUND (alt_sınır), because label noise pulls a placebo contrast toward the placebo.   An interval containing zero → NOT DETECTABLE (saptanamadı) — never "no effect".   An interval excluding zero in the opposite direction → NEGATIVE (negatif), reported as such.</a:t>
+              <a:t>A 95 % bootstrap interval that excludes zero in the expected direction → reported as a LOWER BOUND (alt_sınır), because label noise pulls a placebo contrast toward the placebo (assuming the detector's mistakes are no more informative than random rows — A4).   An interval containing zero → NOT DETECTABLE (saptanamadı) — never "no effect".   An interval excluding zero in the opposite direction → NEGATIVE (negatif), reported as such.</a:t>
             </a:r>
           </a:p>
           <a:p>
@@ -28825,7 +29101,7 @@
                 </a:solidFill>
                 <a:latin typeface="Calibri"/>
               </a:rPr>
-              <a:t>macro-F1 ≥ 0.75  →  measured 0.5404  [0.4897, 0.5869]</a:t>
+              <a:t>macro-F1 ≥ 0.75  →  measured 0.5405  [0.4897, 0.5869]</a:t>
             </a:r>
           </a:p>
           <a:p>
@@ -29087,7 +29363,7 @@
                 </a:solidFill>
                 <a:latin typeface="Calibri"/>
               </a:rPr>
-              <a:t>Label noise makes a gift-deletion condition look MORE like its random-deletion placebo, not less. So every effect on the next slides is a lower bound, and the direction cannot be an artefact of a weak detector.</a:t>
+              <a:t>The placebo holds the amount of deleted data fixed, and the effect scales with the gift share — neither depends on detector accuracy. What the weak detector changes is what is measured: the rows it FLAGS as gifts.</a:t>
             </a:r>
           </a:p>
         </p:txBody>
@@ -29341,8 +29617,8 @@
         </p:blipFill>
         <p:spPr>
           <a:xfrm>
-            <a:off x="658368" y="2222389"/>
-            <a:ext cx="5760720" cy="2870420"/>
+            <a:off x="658368" y="2272085"/>
+            <a:ext cx="5760720" cy="2771029"/>
           </a:xfrm>
           <a:prstGeom prst="rect">
             <a:avLst/>

</xml_diff>

<commit_message>
Iki dogrulamanin sonucu belgelere islendi; B/C sayfalari insan etiketi degil
- Seed 42 yeniden kosusu: SONUCLAR §7 madde 6 ve §8, GENEL_BAKIS, README'ler,
  final raporu §9/§10, deck A4 satir 6 ve A5 (sayilar reproduction_seed42.json'dan).
- B ve C: donen iki sayfa yapay zeka / betik yardimiyla doldurulmustu (kullanici
  teyit etti). Ingest edilmedi, hicbir sayiya girmedi; kappa olculmedi, Hafta 4
  kapisi INCOMPLETE. DECISIONS 2026-09-22, SONUCLAR §7 madde 3, rapor §6.4/§9/§11,
  ETIKETLEME_REHBERI, CLAUDE.md, deck A4 satir 3 ve notlar.
- Birincil sayi degismedi. Deck ve one-pager yeniden uretildi (tarih 22 Eylul);
  degisen slaytlar gozle kontrol edildi. 463 test geciyor.

Co-Authored-By: Claude Opus 5 <noreply@anthropic.com>
Claude-Session: https://claude.ai/code/session_01Boyy948tsSoPXhsYxyoSPt
</commit_message>
<xml_diff>
--- a/presentation/SIC_AI_17_Group_2.pptx
+++ b/presentation/SIC_AI_17_Group_2.pptx
@@ -1433,7 +1433,7 @@
           <a:lstStyle/>
           <a:p>
             <a:r>
-              <a:t>Sinirliliklari juri sormadan biz soyluyoruz. Ilk uç madde dedektorun dogrulugu ve etiket guvenilirligiyle ilgili ve en agirlari. Dorduncusu ince ama onemli: C1 aslinda 'hediyeleri sil' degil 'dedektorun isaretledigini sil' kosulu. Besincisi sirali modele ozel ve etkisinin yonu sinanmadi. Altincisi bir kayit eksikligi: seed 42'nin yirmi dort hucresi ayni veriyle yeniden kosuluyor. Yedi ve sekiz ikinci denetimde bulundu: guven araliklari egitim degiskenligini kapsamiyor ve plasebo kullanici duzeyinde eslenmedi - ikisi de post-hoc olculdu ve Toys bulgusunu degistirmiyor. Dokuzuncusu alt sinir okumasinin varsayimi. Geri kalan on madde SONUCLAR.md yedinci bolumde.</a:t>
+              <a:t>Sinirliliklari juri sormadan biz soyluyoruz. Ilk uç madde dedektorun dogrulugu ve etiket guvenilirligiyle ilgili ve en agirlari. Dorduncusu ince ama onemli: C1 aslinda 'hediyeleri sil' degil 'dedektorun isaretledigini sil' kosulu. Besincisi sirali modele ozel ve etkisinin yonu sinanmadi. Ucuncusu icin Eylul'de ikinci bir tur denedik ama donen sayfalar yapay zeka yardimiyla doldurulmustu; insan etiketi saymadik. Altincisi bir kayit eksikligiydi: seed 42'nin yirmi dort hucresini bugunku kodla yeniden kosturduk, yirmi dordu de bit bit ayni cikti; yirmi bir ile yetmis yedi epoch arasinda erken durdular, hicbiri uc yuz tavanina yaklasmadi. Yedi ve sekiz ikinci denetimde bulundu: guven araliklari egitim degiskenligini kapsamiyor ve plasebo kullanici duzeyinde eslenmedi - ikisi de post-hoc olculdu ve Toys bulgusunu degistirmiyor. Dokuzuncusu alt sinir okumasinin varsayimi. Geri kalan on madde SONUCLAR.md yedinci bolumde.</a:t>
             </a:r>
           </a:p>
         </p:txBody>
@@ -1503,7 +1503,7 @@
           <a:lstStyle/>
           <a:p>
             <a:r>
-              <a:t>Son ek slayt: her sayiyi nasil kontrol edeceginizi anlatiyor. Baslangiç noktasi demo betigi - veri dosyasi olmadan, standart kutuphaneyle, commit'li JSON'lardan butun basliklari basiyor. Sagdaki provenans kutusu her artefaktin hangi kod surumuyle uretildigini gosteriyor; 'dirty' eki calisma agacinda commit edilmemis KOD degisikligi vardi demek. Alt tabloda neyin commit edilip neyin edilmedigi var: veri ve model agirliklari kasitli olarak depoda yok. Bu deck'i ureten betik de ayni JSON'lari okuyor, yani slaytlar artefaktlardan sapamaz.</a:t>
+              <a:t>Son ek slayt: her sayiyi nasil kontrol edeceginizi anlatiyor. Baslangiç noktasi demo betigi - veri dosyasi olmadan, standart kutuphaneyle, commit'li JSON'lardan butun basliklari basiyor. Sagdaki provenans kutusu her artefaktin hangi kod surumuyle uretildigini gosteriyor; 'dirty' eki calisma agacinda commit edilmemis KOD degisikligi vardi demek. Alt tabloda neyin commit edilip neyin edilmedigi var: veri ve model agirliklari kasitli olarak depoda yok. Bu deck'i ureten betik de ayni JSON'lari okuyor, yani slaytlar artefaktlardan sapamaz. En altta: seed 42'nin yirmi dort hucresini bugunku kodla yeniden kosturduk ve yirmi dordu de bit bit ayni cikti.</a:t>
             </a:r>
           </a:p>
         </p:txBody>
@@ -1853,7 +1853,7 @@
           <a:lstStyle/>
           <a:p>
             <a:r>
-              <a:t>Bu slaydi atlamiyoruz, aksine one aliyoruz. Concept note'ta iki esik yazmisiz: makro-F1 en az sifir yetmis bes ve hediye kesinligi en az sifir seksen. Olculen degerler sifir elli dort ve sifir altmis sekiz - ikisi de tutmuyor. Ayrica tek etiketleyici calisti, yani planlanan Fleiss kappa hic olculmedi; Hafta 4'un artefakttaki karari INCOMPLETE. Peki calisma neden hala okunabilir? Iki sey dedektorun dogruluguna bagli degil: plasebo silinen veri miktarini sabit tutuyor, ve etki kategorinin hediye payiyla buyuyor. Zayif dedektorun degistirdigi sey ne olculdugu: 'hediyeler' degil, dedektorun hediye DEDIGI satirlar. Bunlarin ucte biri insana gore hediye degil, cogu kendi cocuguna alim - o yuzden 'alt sinir' okumasi bir varsayima dayaniyor, A4'te yaziyor.</a:t>
+              <a:t>Bu slaydi atlamiyoruz, aksine one aliyoruz. Concept note'ta iki esik yazmisiz: makro-F1 en az sifir yetmis bes ve hediye kesinligi en az sifir seksen. Olculen degerler sifir elli dort ve sifir altmis sekiz - ikisi de tutmuyor. Ayrica tek etiketleyici calisti, yani planlanan Fleiss kappa hic olculmedi; Hafta 4'un artefakttaki karari INCOMPLETE. Peki calisma neden hala okunabilir? Iki sey dedektorun dogruluguna bagli degil: plasebo silinen veri miktarini sabit tutuyor, ve etki kategorinin hediye payiyla buyuyor. Zayif dedektorun degistirdigi sey ne olculdugu: 'hediyeler' degil, dedektorun hediye DEDIGI satirlar. Bunlarin ucte biri insana gore hediye degil, cogu kendi cocuguna alim - o yuzden 'alt sinir' okumasi bir varsayima dayaniyor, A4'te yaziyor. Eylul'de ikinci ve ucuncu etiketleyiciyle bir tur daha denedik; donen sayfalar yapay zeka yardimiyla doldurulmustu, insan etiketi saymadik. Yani kappa hala olculmedi.</a:t>
             </a:r>
           </a:p>
         </p:txBody>
@@ -5275,7 +5275,7 @@
                 </a:solidFill>
                 <a:latin typeface="Calibri"/>
               </a:rPr>
-              <a:t>github.com/edasaruhan/SIC_AI_17_Capstone_Group_2  ·  21 September 2026</a:t>
+              <a:t>github.com/edasaruhan/SIC_AI_17_Capstone_Group_2  ·  22 September 2026</a:t>
             </a:r>
           </a:p>
           <a:p>
@@ -22334,7 +22334,7 @@
                           </a:solidFill>
                           <a:latin typeface="Calibri"/>
                         </a:rPr>
-                        <a:t>No reliability estimate for the reference labels themselves</a:t>
+                        <a:t>No reliability estimate for the reference labels; a September retry came back AI-assisted and was discarded</a:t>
                       </a:r>
                     </a:p>
                   </a:txBody>
@@ -22580,7 +22580,7 @@
                           </a:solidFill>
                           <a:latin typeface="Calibri"/>
                         </a:rPr>
-                        <a:t>Number of epochs actually trained was not recorded for the 72 runs</a:t>
+                        <a:t>Epochs trained were not recorded for the 72 original runs</a:t>
                       </a:r>
                     </a:p>
                   </a:txBody>
@@ -22610,7 +22610,7 @@
                           </a:solidFill>
                           <a:latin typeface="Calibri"/>
                         </a:rPr>
-                        <a:t>Seed-42 cells re-run on 21 Sept with the same data to measure it</a:t>
+                        <a:t>Seed-42 re-run: 24/24 bit-identical, 21–77 epochs, none at the 300 cap</a:t>
                       </a:r>
                     </a:p>
                   </a:txBody>
@@ -23694,7 +23694,7 @@
                 </a:solidFill>
                 <a:latin typeface="Calibri"/>
               </a:rPr>
-              <a:t>Code, configs, 441 tests, every result JSON, every figure, the report and this deck's generator</a:t>
+              <a:t>Code, configs, 463 tests, every result JSON, every figure, the report and this deck's generator</a:t>
             </a:r>
           </a:p>
         </p:txBody>
@@ -23851,7 +23851,7 @@
                 </a:solidFill>
                 <a:latin typeface="Calibri"/>
               </a:rPr>
-              <a:t>Two virtual environments: .venv for the pipeline (polars 1.44, numpy 2.5) and .venv-recbole for the experiment (numpy &lt; 2, because RecBole 1.2.0 still uses np.float_). Slides were generated by presentation/build_deck.py, which reads the same JSONs — so the deck cannot drift from the artefacts.</a:t>
+              <a:t>Two virtual environments: .venv for the pipeline (polars 1.44, numpy 2.5) and .venv-recbole for the experiment (numpy &lt; 2, because RecBole 1.2.0 still uses np.float_). Slides were generated by presentation/build_deck.py, which reads the same JSONs — so the deck cannot drift from the artefacts. The 24 seed-42 cells were re-run with the current code: 24/24 bit-identical (reproduction_seed42.json).</a:t>
             </a:r>
           </a:p>
         </p:txBody>

</xml_diff>